<commit_message>
docs: update sprint deck timeline to run through January
Timeline is now month based, October to late January. Also lowercases the d in Ethan de Guzman.

Co-Authored-By: Claude Sonnet 5.5 <noreply@anthropic.com>
</commit_message>
<xml_diff>
--- a/docs/Ascend_Sprint_Review_1.pptx
+++ b/docs/Ascend_Sprint_Review_1.pptx
@@ -1438,7 +1438,7 @@
           <a:p>
             <a:r>
               <a:rPr lang="en-US" dirty="0"/>
-              <a:t>This is a proposed schedule counted in weeks from today. Adjust the week ranges to match the real course calendar before presenting.</a:t>
+              <a:t>This is a proposed schedule from October through the end of the project in January. Adjust the months to match the real course calendar before presenting.</a:t>
             </a:r>
             <a:endParaRPr lang="en-US" dirty="0"/>
           </a:p>
@@ -2339,7 +2339,7 @@
                 <a:ea typeface="Arial" pitchFamily="34" charset="-122"/>
                 <a:cs typeface="Arial" pitchFamily="34" charset="-120"/>
               </a:rPr>
-              <a:t>Aaryaman Chopra, Ethan De Guzman,</a:t>
+              <a:t>Aaryaman Chopra, Ethan de Guzman,</a:t>
             </a:r>
             <a:endParaRPr lang="en-US" sz="2100" dirty="0"/>
           </a:p>
@@ -3716,7 +3716,7 @@
                 <a:ea typeface="Arial" pitchFamily="34" charset="-122"/>
                 <a:cs typeface="Arial" pitchFamily="34" charset="-120"/>
               </a:rPr>
-              <a:t>Ethan De Guzman</a:t>
+              <a:t>Ethan de Guzman</a:t>
             </a:r>
             <a:endParaRPr lang="en-US" sz="1700" dirty="0"/>
           </a:p>
@@ -6625,7 +6625,7 @@
                 <a:ea typeface="Arial" pitchFamily="34" charset="-122"/>
                 <a:cs typeface="Arial" pitchFamily="34" charset="-120"/>
               </a:rPr>
-              <a:t>Proposed schedule, starting after this review</a:t>
+              <a:t>Proposed schedule, October through January</a:t>
             </a:r>
             <a:endParaRPr lang="en-US" sz="1500" dirty="0"/>
           </a:p>
@@ -6687,7 +6687,7 @@
                 <a:ea typeface="Arial" pitchFamily="34" charset="-122"/>
                 <a:cs typeface="Arial" pitchFamily="34" charset="-120"/>
               </a:rPr>
-              <a:t>WEEKS 1 TO 2</a:t>
+              <a:t>OCTOBER</a:t>
             </a:r>
             <a:endParaRPr lang="en-US" sz="1100" dirty="0"/>
           </a:p>
@@ -6852,7 +6852,7 @@
                 <a:ea typeface="Arial" pitchFamily="34" charset="-122"/>
                 <a:cs typeface="Arial" pitchFamily="34" charset="-120"/>
               </a:rPr>
-              <a:t>WEEKS 3 TO 4</a:t>
+              <a:t>NOVEMBER</a:t>
             </a:r>
             <a:endParaRPr lang="en-US" sz="1100" dirty="0"/>
           </a:p>
@@ -7017,7 +7017,7 @@
                 <a:ea typeface="Arial" pitchFamily="34" charset="-122"/>
                 <a:cs typeface="Arial" pitchFamily="34" charset="-120"/>
               </a:rPr>
-              <a:t>WEEKS 5 TO 6</a:t>
+              <a:t>DECEMBER</a:t>
             </a:r>
             <a:endParaRPr lang="en-US" sz="1100" dirty="0"/>
           </a:p>
@@ -7182,7 +7182,7 @@
                 <a:ea typeface="Arial" pitchFamily="34" charset="-122"/>
                 <a:cs typeface="Arial" pitchFamily="34" charset="-120"/>
               </a:rPr>
-              <a:t>WEEKS 7 TO 8</a:t>
+              <a:t>EARLY JANUARY</a:t>
             </a:r>
             <a:endParaRPr lang="en-US" sz="1100" dirty="0"/>
           </a:p>
@@ -7347,7 +7347,7 @@
                 <a:ea typeface="Arial" pitchFamily="34" charset="-122"/>
                 <a:cs typeface="Arial" pitchFamily="34" charset="-120"/>
               </a:rPr>
-              <a:t>FINAL WEEK</a:t>
+              <a:t>LATE JANUARY</a:t>
             </a:r>
             <a:endParaRPr lang="en-US" sz="1100" dirty="0"/>
           </a:p>
@@ -7473,7 +7473,7 @@
                 <a:ea typeface="Arial" pitchFamily="34" charset="-122"/>
                 <a:cs typeface="Arial" pitchFamily="34" charset="-120"/>
               </a:rPr>
-              <a:t>Polish and demo</a:t>
+              <a:t>Polish and final demo</a:t>
             </a:r>
             <a:endParaRPr lang="en-US" sz="1250" dirty="0"/>
           </a:p>
@@ -7526,7 +7526,7 @@
                 <a:ea typeface="Arial" pitchFamily="34" charset="-122"/>
                 <a:cs typeface="Arial" pitchFamily="34" charset="-120"/>
               </a:rPr>
-              <a:t>weekly check-ins, GitHub reviews, and a sprint review each phase.</a:t>
+              <a:t>weekly check-ins, GitHub reviews, and a sprint review along the way.</a:t>
             </a:r>
             <a:endParaRPr lang="en-US" sz="1600" dirty="0"/>
           </a:p>
@@ -9092,7 +9092,7 @@
                 <a:ea typeface="Arial" pitchFamily="34" charset="-122"/>
                 <a:cs typeface="Arial" pitchFamily="34" charset="-120"/>
               </a:rPr>
-              <a:t>Aaryaman Chopra   |   Ethan De Guzman   |   Palash Desarda   |   Kaiyaan Faisal</a:t>
+              <a:t>Aaryaman Chopra   |   Ethan de Guzman   |   Palash Desarda   |   Kaiyaan Faisal</a:t>
             </a:r>
             <a:endParaRPr lang="en-US" sz="1400" dirty="0"/>
           </a:p>

</xml_diff>